<commit_message>
Regenerate repository videos with Japanese slides
</commit_message>
<xml_diff>
--- a/public/videos/repositories/akecom-spa2x-ryu/akecom-spa2x-ryu-tech-preview.pptx
+++ b/public/videos/repositories/akecom-spa2x-ryu/akecom-spa2x-ryu-tech-preview.pptx
@@ -134,7 +134,7 @@
           <p:cNvPr id="2" name="タイトル 1">
             <a:extLst>
               <a:ext uri="{FF2B5EF4-FFF2-40B4-BE49-F238E27FC236}">
-                <a16:creationId xmlns:a16="http://schemas.microsoft.com/office/drawing/2014/main" id="{DCF4FD7E-888C-4B96-2A63-A4314D6A32C7}"/>
+                <a16:creationId xmlns:a16="http://schemas.microsoft.com/office/drawing/2014/main" id="{FE423AE3-3265-A919-F809-82D98909DFFB}"/>
               </a:ext>
             </a:extLst>
           </p:cNvPr>
@@ -171,7 +171,7 @@
           <p:cNvPr id="3" name="字幕 2">
             <a:extLst>
               <a:ext uri="{FF2B5EF4-FFF2-40B4-BE49-F238E27FC236}">
-                <a16:creationId xmlns:a16="http://schemas.microsoft.com/office/drawing/2014/main" id="{BFC7A3BC-2928-65A8-3DC6-6D8B5BF6D5C2}"/>
+                <a16:creationId xmlns:a16="http://schemas.microsoft.com/office/drawing/2014/main" id="{85FE0711-8477-BF40-60A5-B265506625B5}"/>
               </a:ext>
             </a:extLst>
           </p:cNvPr>
@@ -241,7 +241,7 @@
           <p:cNvPr id="4" name="日付プレースホルダー 3">
             <a:extLst>
               <a:ext uri="{FF2B5EF4-FFF2-40B4-BE49-F238E27FC236}">
-                <a16:creationId xmlns:a16="http://schemas.microsoft.com/office/drawing/2014/main" id="{62675D03-57CF-3512-8E7D-190D8C8437FE}"/>
+                <a16:creationId xmlns:a16="http://schemas.microsoft.com/office/drawing/2014/main" id="{3B953FFA-F30B-D5CC-E4D6-5F93FFC843BD}"/>
               </a:ext>
             </a:extLst>
           </p:cNvPr>
@@ -257,7 +257,7 @@
           <a:bodyPr/>
           <a:lstStyle/>
           <a:p>
-            <a:fld id="{B6352141-9843-4316-BBDD-32833FECAE64}" type="datetimeFigureOut">
+            <a:fld id="{16C84519-D319-46E2-8FEF-E30A6544EB7B}" type="datetimeFigureOut">
               <a:rPr kumimoji="1" lang="ja-JP" altLang="en-US" smtClean="0"/>
               <a:t>2026/7/30</a:t>
             </a:fld>
@@ -270,7 +270,7 @@
           <p:cNvPr id="5" name="フッター プレースホルダー 4">
             <a:extLst>
               <a:ext uri="{FF2B5EF4-FFF2-40B4-BE49-F238E27FC236}">
-                <a16:creationId xmlns:a16="http://schemas.microsoft.com/office/drawing/2014/main" id="{1212AB89-A831-37E6-FDD5-50EA185FEF84}"/>
+                <a16:creationId xmlns:a16="http://schemas.microsoft.com/office/drawing/2014/main" id="{DFD0B940-88DE-C6D6-E73A-80598CE78FC1}"/>
               </a:ext>
             </a:extLst>
           </p:cNvPr>
@@ -295,7 +295,7 @@
           <p:cNvPr id="6" name="スライド番号プレースホルダー 5">
             <a:extLst>
               <a:ext uri="{FF2B5EF4-FFF2-40B4-BE49-F238E27FC236}">
-                <a16:creationId xmlns:a16="http://schemas.microsoft.com/office/drawing/2014/main" id="{93C89CC8-F86D-AE4F-00DA-2E536A7D0BD0}"/>
+                <a16:creationId xmlns:a16="http://schemas.microsoft.com/office/drawing/2014/main" id="{0AD3C761-6FAA-8413-7674-5B800B75E021}"/>
               </a:ext>
             </a:extLst>
           </p:cNvPr>
@@ -311,7 +311,7 @@
           <a:bodyPr/>
           <a:lstStyle/>
           <a:p>
-            <a:fld id="{2144295E-E99D-4840-ACBC-FAC7FF7804ED}" type="slidenum">
+            <a:fld id="{03EEC84A-F438-4B8D-8613-D1012426F156}" type="slidenum">
               <a:rPr kumimoji="1" lang="ja-JP" altLang="en-US" smtClean="0"/>
               <a:t>‹#›</a:t>
             </a:fld>
@@ -322,7 +322,7 @@
     </p:spTree>
     <p:extLst>
       <p:ext uri="{BB962C8B-B14F-4D97-AF65-F5344CB8AC3E}">
-        <p14:creationId xmlns:p14="http://schemas.microsoft.com/office/powerpoint/2010/main" val="2401172628"/>
+        <p14:creationId xmlns:p14="http://schemas.microsoft.com/office/powerpoint/2010/main" val="1773892475"/>
       </p:ext>
     </p:extLst>
   </p:cSld>
@@ -354,7 +354,7 @@
           <p:cNvPr id="2" name="タイトル 1">
             <a:extLst>
               <a:ext uri="{FF2B5EF4-FFF2-40B4-BE49-F238E27FC236}">
-                <a16:creationId xmlns:a16="http://schemas.microsoft.com/office/drawing/2014/main" id="{521509A3-AC3A-58DF-853E-F1CD7BA9AC21}"/>
+                <a16:creationId xmlns:a16="http://schemas.microsoft.com/office/drawing/2014/main" id="{86EA480E-2BB1-16D4-020A-6F3F3D698CF6}"/>
               </a:ext>
             </a:extLst>
           </p:cNvPr>
@@ -382,7 +382,7 @@
           <p:cNvPr id="3" name="縦書きテキスト プレースホルダー 2">
             <a:extLst>
               <a:ext uri="{FF2B5EF4-FFF2-40B4-BE49-F238E27FC236}">
-                <a16:creationId xmlns:a16="http://schemas.microsoft.com/office/drawing/2014/main" id="{A89CFA9D-7641-2590-4E3C-3D459FBED749}"/>
+                <a16:creationId xmlns:a16="http://schemas.microsoft.com/office/drawing/2014/main" id="{B8F07D31-06F2-F855-30F9-C20D2FB948F4}"/>
               </a:ext>
             </a:extLst>
           </p:cNvPr>
@@ -471,7 +471,7 @@
           <p:cNvPr id="4" name="日付プレースホルダー 3">
             <a:extLst>
               <a:ext uri="{FF2B5EF4-FFF2-40B4-BE49-F238E27FC236}">
-                <a16:creationId xmlns:a16="http://schemas.microsoft.com/office/drawing/2014/main" id="{FE5F7D63-8DB3-3215-D4ED-EF9E831DD533}"/>
+                <a16:creationId xmlns:a16="http://schemas.microsoft.com/office/drawing/2014/main" id="{F5880CB0-C9C3-FDE9-AEB9-03EF4F556EF4}"/>
               </a:ext>
             </a:extLst>
           </p:cNvPr>
@@ -487,7 +487,7 @@
           <a:bodyPr/>
           <a:lstStyle/>
           <a:p>
-            <a:fld id="{B6352141-9843-4316-BBDD-32833FECAE64}" type="datetimeFigureOut">
+            <a:fld id="{16C84519-D319-46E2-8FEF-E30A6544EB7B}" type="datetimeFigureOut">
               <a:rPr kumimoji="1" lang="ja-JP" altLang="en-US" smtClean="0"/>
               <a:t>2026/7/30</a:t>
             </a:fld>
@@ -500,7 +500,7 @@
           <p:cNvPr id="5" name="フッター プレースホルダー 4">
             <a:extLst>
               <a:ext uri="{FF2B5EF4-FFF2-40B4-BE49-F238E27FC236}">
-                <a16:creationId xmlns:a16="http://schemas.microsoft.com/office/drawing/2014/main" id="{D8B93FC5-6CD4-F9AD-E9AA-3548C1CC5DC1}"/>
+                <a16:creationId xmlns:a16="http://schemas.microsoft.com/office/drawing/2014/main" id="{3189574A-9868-0509-B058-14DBF6B849A2}"/>
               </a:ext>
             </a:extLst>
           </p:cNvPr>
@@ -525,7 +525,7 @@
           <p:cNvPr id="6" name="スライド番号プレースホルダー 5">
             <a:extLst>
               <a:ext uri="{FF2B5EF4-FFF2-40B4-BE49-F238E27FC236}">
-                <a16:creationId xmlns:a16="http://schemas.microsoft.com/office/drawing/2014/main" id="{B993BCD5-08B7-FD5C-C3BA-889FB0C327E9}"/>
+                <a16:creationId xmlns:a16="http://schemas.microsoft.com/office/drawing/2014/main" id="{B9E2F3B7-4799-DBDF-0EAB-F8391D326565}"/>
               </a:ext>
             </a:extLst>
           </p:cNvPr>
@@ -541,7 +541,7 @@
           <a:bodyPr/>
           <a:lstStyle/>
           <a:p>
-            <a:fld id="{2144295E-E99D-4840-ACBC-FAC7FF7804ED}" type="slidenum">
+            <a:fld id="{03EEC84A-F438-4B8D-8613-D1012426F156}" type="slidenum">
               <a:rPr kumimoji="1" lang="ja-JP" altLang="en-US" smtClean="0"/>
               <a:t>‹#›</a:t>
             </a:fld>
@@ -552,7 +552,7 @@
     </p:spTree>
     <p:extLst>
       <p:ext uri="{BB962C8B-B14F-4D97-AF65-F5344CB8AC3E}">
-        <p14:creationId xmlns:p14="http://schemas.microsoft.com/office/powerpoint/2010/main" val="3393106236"/>
+        <p14:creationId xmlns:p14="http://schemas.microsoft.com/office/powerpoint/2010/main" val="3810160012"/>
       </p:ext>
     </p:extLst>
   </p:cSld>
@@ -584,7 +584,7 @@
           <p:cNvPr id="2" name="縦書きタイトル 1">
             <a:extLst>
               <a:ext uri="{FF2B5EF4-FFF2-40B4-BE49-F238E27FC236}">
-                <a16:creationId xmlns:a16="http://schemas.microsoft.com/office/drawing/2014/main" id="{9E204B74-8DDD-56A4-4D25-E4D60E703716}"/>
+                <a16:creationId xmlns:a16="http://schemas.microsoft.com/office/drawing/2014/main" id="{0C1AF558-1410-B3A5-4359-F8006799F9B3}"/>
               </a:ext>
             </a:extLst>
           </p:cNvPr>
@@ -617,7 +617,7 @@
           <p:cNvPr id="3" name="縦書きテキスト プレースホルダー 2">
             <a:extLst>
               <a:ext uri="{FF2B5EF4-FFF2-40B4-BE49-F238E27FC236}">
-                <a16:creationId xmlns:a16="http://schemas.microsoft.com/office/drawing/2014/main" id="{C7674E74-2BF0-C8FD-74CA-3540C18ACBEE}"/>
+                <a16:creationId xmlns:a16="http://schemas.microsoft.com/office/drawing/2014/main" id="{3BD6E997-2561-A4E5-C275-29CE52B4ABF1}"/>
               </a:ext>
             </a:extLst>
           </p:cNvPr>
@@ -711,7 +711,7 @@
           <p:cNvPr id="4" name="日付プレースホルダー 3">
             <a:extLst>
               <a:ext uri="{FF2B5EF4-FFF2-40B4-BE49-F238E27FC236}">
-                <a16:creationId xmlns:a16="http://schemas.microsoft.com/office/drawing/2014/main" id="{2C2C189F-6D34-202D-1C62-A4D6867C38CA}"/>
+                <a16:creationId xmlns:a16="http://schemas.microsoft.com/office/drawing/2014/main" id="{A0762F29-FA51-16B8-8FD6-C97FDBB97662}"/>
               </a:ext>
             </a:extLst>
           </p:cNvPr>
@@ -727,7 +727,7 @@
           <a:bodyPr/>
           <a:lstStyle/>
           <a:p>
-            <a:fld id="{B6352141-9843-4316-BBDD-32833FECAE64}" type="datetimeFigureOut">
+            <a:fld id="{16C84519-D319-46E2-8FEF-E30A6544EB7B}" type="datetimeFigureOut">
               <a:rPr kumimoji="1" lang="ja-JP" altLang="en-US" smtClean="0"/>
               <a:t>2026/7/30</a:t>
             </a:fld>
@@ -740,7 +740,7 @@
           <p:cNvPr id="5" name="フッター プレースホルダー 4">
             <a:extLst>
               <a:ext uri="{FF2B5EF4-FFF2-40B4-BE49-F238E27FC236}">
-                <a16:creationId xmlns:a16="http://schemas.microsoft.com/office/drawing/2014/main" id="{AF6A6CFD-DCF2-6211-0A7B-99BBCD364D59}"/>
+                <a16:creationId xmlns:a16="http://schemas.microsoft.com/office/drawing/2014/main" id="{5B643A38-8064-E15B-439E-5CC8FCF21BB2}"/>
               </a:ext>
             </a:extLst>
           </p:cNvPr>
@@ -765,7 +765,7 @@
           <p:cNvPr id="6" name="スライド番号プレースホルダー 5">
             <a:extLst>
               <a:ext uri="{FF2B5EF4-FFF2-40B4-BE49-F238E27FC236}">
-                <a16:creationId xmlns:a16="http://schemas.microsoft.com/office/drawing/2014/main" id="{51C275A3-5BC4-A138-1A6A-60CFEC94DD2A}"/>
+                <a16:creationId xmlns:a16="http://schemas.microsoft.com/office/drawing/2014/main" id="{4756362C-BFD5-7036-E076-7E9B2D64D70A}"/>
               </a:ext>
             </a:extLst>
           </p:cNvPr>
@@ -781,7 +781,7 @@
           <a:bodyPr/>
           <a:lstStyle/>
           <a:p>
-            <a:fld id="{2144295E-E99D-4840-ACBC-FAC7FF7804ED}" type="slidenum">
+            <a:fld id="{03EEC84A-F438-4B8D-8613-D1012426F156}" type="slidenum">
               <a:rPr kumimoji="1" lang="ja-JP" altLang="en-US" smtClean="0"/>
               <a:t>‹#›</a:t>
             </a:fld>
@@ -792,7 +792,7 @@
     </p:spTree>
     <p:extLst>
       <p:ext uri="{BB962C8B-B14F-4D97-AF65-F5344CB8AC3E}">
-        <p14:creationId xmlns:p14="http://schemas.microsoft.com/office/powerpoint/2010/main" val="1613643184"/>
+        <p14:creationId xmlns:p14="http://schemas.microsoft.com/office/powerpoint/2010/main" val="929123398"/>
       </p:ext>
     </p:extLst>
   </p:cSld>
@@ -824,7 +824,7 @@
           <p:cNvPr id="2" name="タイトル 1">
             <a:extLst>
               <a:ext uri="{FF2B5EF4-FFF2-40B4-BE49-F238E27FC236}">
-                <a16:creationId xmlns:a16="http://schemas.microsoft.com/office/drawing/2014/main" id="{0C03D294-4914-D736-9405-50A018270BE1}"/>
+                <a16:creationId xmlns:a16="http://schemas.microsoft.com/office/drawing/2014/main" id="{1439682C-1E70-8300-AB00-7652E4BDCD6B}"/>
               </a:ext>
             </a:extLst>
           </p:cNvPr>
@@ -852,7 +852,7 @@
           <p:cNvPr id="3" name="コンテンツ プレースホルダー 2">
             <a:extLst>
               <a:ext uri="{FF2B5EF4-FFF2-40B4-BE49-F238E27FC236}">
-                <a16:creationId xmlns:a16="http://schemas.microsoft.com/office/drawing/2014/main" id="{3BEBF2C5-3D22-D924-7472-AE33EFE2388F}"/>
+                <a16:creationId xmlns:a16="http://schemas.microsoft.com/office/drawing/2014/main" id="{45FCF19E-57A4-B80B-8E9F-8C5A8B63BCCC}"/>
               </a:ext>
             </a:extLst>
           </p:cNvPr>
@@ -941,7 +941,7 @@
           <p:cNvPr id="4" name="日付プレースホルダー 3">
             <a:extLst>
               <a:ext uri="{FF2B5EF4-FFF2-40B4-BE49-F238E27FC236}">
-                <a16:creationId xmlns:a16="http://schemas.microsoft.com/office/drawing/2014/main" id="{4ED5377B-A1DC-04D2-8C9C-F5709AF5DDAC}"/>
+                <a16:creationId xmlns:a16="http://schemas.microsoft.com/office/drawing/2014/main" id="{CDED14C7-3241-6037-05D2-FC4FA519E1AE}"/>
               </a:ext>
             </a:extLst>
           </p:cNvPr>
@@ -957,7 +957,7 @@
           <a:bodyPr/>
           <a:lstStyle/>
           <a:p>
-            <a:fld id="{B6352141-9843-4316-BBDD-32833FECAE64}" type="datetimeFigureOut">
+            <a:fld id="{16C84519-D319-46E2-8FEF-E30A6544EB7B}" type="datetimeFigureOut">
               <a:rPr kumimoji="1" lang="ja-JP" altLang="en-US" smtClean="0"/>
               <a:t>2026/7/30</a:t>
             </a:fld>
@@ -970,7 +970,7 @@
           <p:cNvPr id="5" name="フッター プレースホルダー 4">
             <a:extLst>
               <a:ext uri="{FF2B5EF4-FFF2-40B4-BE49-F238E27FC236}">
-                <a16:creationId xmlns:a16="http://schemas.microsoft.com/office/drawing/2014/main" id="{899D222D-27EA-6B89-3DCF-0DD69FE88E1A}"/>
+                <a16:creationId xmlns:a16="http://schemas.microsoft.com/office/drawing/2014/main" id="{0F028EE9-756A-1F1C-9DE3-CFEF3EEF0A4A}"/>
               </a:ext>
             </a:extLst>
           </p:cNvPr>
@@ -995,7 +995,7 @@
           <p:cNvPr id="6" name="スライド番号プレースホルダー 5">
             <a:extLst>
               <a:ext uri="{FF2B5EF4-FFF2-40B4-BE49-F238E27FC236}">
-                <a16:creationId xmlns:a16="http://schemas.microsoft.com/office/drawing/2014/main" id="{B66D1AA0-1EA5-10E5-B90A-BD96E9F1F2D6}"/>
+                <a16:creationId xmlns:a16="http://schemas.microsoft.com/office/drawing/2014/main" id="{D5734E79-14A7-9EDA-35A9-42F74EAA77BA}"/>
               </a:ext>
             </a:extLst>
           </p:cNvPr>
@@ -1011,7 +1011,7 @@
           <a:bodyPr/>
           <a:lstStyle/>
           <a:p>
-            <a:fld id="{2144295E-E99D-4840-ACBC-FAC7FF7804ED}" type="slidenum">
+            <a:fld id="{03EEC84A-F438-4B8D-8613-D1012426F156}" type="slidenum">
               <a:rPr kumimoji="1" lang="ja-JP" altLang="en-US" smtClean="0"/>
               <a:t>‹#›</a:t>
             </a:fld>
@@ -1022,7 +1022,7 @@
     </p:spTree>
     <p:extLst>
       <p:ext uri="{BB962C8B-B14F-4D97-AF65-F5344CB8AC3E}">
-        <p14:creationId xmlns:p14="http://schemas.microsoft.com/office/powerpoint/2010/main" val="115398481"/>
+        <p14:creationId xmlns:p14="http://schemas.microsoft.com/office/powerpoint/2010/main" val="762759866"/>
       </p:ext>
     </p:extLst>
   </p:cSld>
@@ -1054,7 +1054,7 @@
           <p:cNvPr id="2" name="タイトル 1">
             <a:extLst>
               <a:ext uri="{FF2B5EF4-FFF2-40B4-BE49-F238E27FC236}">
-                <a16:creationId xmlns:a16="http://schemas.microsoft.com/office/drawing/2014/main" id="{3949B1A9-E44A-5509-ABC2-1FD7DE857C22}"/>
+                <a16:creationId xmlns:a16="http://schemas.microsoft.com/office/drawing/2014/main" id="{B4347EB4-AEFA-49BB-52F5-4E32884D4566}"/>
               </a:ext>
             </a:extLst>
           </p:cNvPr>
@@ -1091,7 +1091,7 @@
           <p:cNvPr id="3" name="テキスト プレースホルダー 2">
             <a:extLst>
               <a:ext uri="{FF2B5EF4-FFF2-40B4-BE49-F238E27FC236}">
-                <a16:creationId xmlns:a16="http://schemas.microsoft.com/office/drawing/2014/main" id="{B70C5DE8-C4DE-616E-DD3B-B16A9AE863DD}"/>
+                <a16:creationId xmlns:a16="http://schemas.microsoft.com/office/drawing/2014/main" id="{6EAC52B6-6378-3665-013B-45A6E4F9021C}"/>
               </a:ext>
             </a:extLst>
           </p:cNvPr>
@@ -1216,7 +1216,7 @@
           <p:cNvPr id="4" name="日付プレースホルダー 3">
             <a:extLst>
               <a:ext uri="{FF2B5EF4-FFF2-40B4-BE49-F238E27FC236}">
-                <a16:creationId xmlns:a16="http://schemas.microsoft.com/office/drawing/2014/main" id="{528E413C-492F-8906-A6AF-FBEA603A12D5}"/>
+                <a16:creationId xmlns:a16="http://schemas.microsoft.com/office/drawing/2014/main" id="{0BAC2D91-B3AC-E012-43D5-AB2636917661}"/>
               </a:ext>
             </a:extLst>
           </p:cNvPr>
@@ -1232,7 +1232,7 @@
           <a:bodyPr/>
           <a:lstStyle/>
           <a:p>
-            <a:fld id="{B6352141-9843-4316-BBDD-32833FECAE64}" type="datetimeFigureOut">
+            <a:fld id="{16C84519-D319-46E2-8FEF-E30A6544EB7B}" type="datetimeFigureOut">
               <a:rPr kumimoji="1" lang="ja-JP" altLang="en-US" smtClean="0"/>
               <a:t>2026/7/30</a:t>
             </a:fld>
@@ -1245,7 +1245,7 @@
           <p:cNvPr id="5" name="フッター プレースホルダー 4">
             <a:extLst>
               <a:ext uri="{FF2B5EF4-FFF2-40B4-BE49-F238E27FC236}">
-                <a16:creationId xmlns:a16="http://schemas.microsoft.com/office/drawing/2014/main" id="{BA5E3394-09A2-6BD4-54D6-A7AAB8B6FF14}"/>
+                <a16:creationId xmlns:a16="http://schemas.microsoft.com/office/drawing/2014/main" id="{85CCB88F-8028-7BD8-891F-E6E360A8A629}"/>
               </a:ext>
             </a:extLst>
           </p:cNvPr>
@@ -1270,7 +1270,7 @@
           <p:cNvPr id="6" name="スライド番号プレースホルダー 5">
             <a:extLst>
               <a:ext uri="{FF2B5EF4-FFF2-40B4-BE49-F238E27FC236}">
-                <a16:creationId xmlns:a16="http://schemas.microsoft.com/office/drawing/2014/main" id="{6247C1F3-0247-4DFE-1E6D-B6EA2B11A319}"/>
+                <a16:creationId xmlns:a16="http://schemas.microsoft.com/office/drawing/2014/main" id="{4D79D4A5-7B87-A36F-B4CB-4197CAC5BBA5}"/>
               </a:ext>
             </a:extLst>
           </p:cNvPr>
@@ -1286,7 +1286,7 @@
           <a:bodyPr/>
           <a:lstStyle/>
           <a:p>
-            <a:fld id="{2144295E-E99D-4840-ACBC-FAC7FF7804ED}" type="slidenum">
+            <a:fld id="{03EEC84A-F438-4B8D-8613-D1012426F156}" type="slidenum">
               <a:rPr kumimoji="1" lang="ja-JP" altLang="en-US" smtClean="0"/>
               <a:t>‹#›</a:t>
             </a:fld>
@@ -1297,7 +1297,7 @@
     </p:spTree>
     <p:extLst>
       <p:ext uri="{BB962C8B-B14F-4D97-AF65-F5344CB8AC3E}">
-        <p14:creationId xmlns:p14="http://schemas.microsoft.com/office/powerpoint/2010/main" val="1851983225"/>
+        <p14:creationId xmlns:p14="http://schemas.microsoft.com/office/powerpoint/2010/main" val="2268688079"/>
       </p:ext>
     </p:extLst>
   </p:cSld>
@@ -1329,7 +1329,7 @@
           <p:cNvPr id="2" name="タイトル 1">
             <a:extLst>
               <a:ext uri="{FF2B5EF4-FFF2-40B4-BE49-F238E27FC236}">
-                <a16:creationId xmlns:a16="http://schemas.microsoft.com/office/drawing/2014/main" id="{C4783A0C-31C1-CC3F-3E69-EDE48DFA6B4B}"/>
+                <a16:creationId xmlns:a16="http://schemas.microsoft.com/office/drawing/2014/main" id="{5CEC0FF6-BF59-130E-824A-9465DB27FFCF}"/>
               </a:ext>
             </a:extLst>
           </p:cNvPr>
@@ -1357,7 +1357,7 @@
           <p:cNvPr id="3" name="コンテンツ プレースホルダー 2">
             <a:extLst>
               <a:ext uri="{FF2B5EF4-FFF2-40B4-BE49-F238E27FC236}">
-                <a16:creationId xmlns:a16="http://schemas.microsoft.com/office/drawing/2014/main" id="{FB75B983-BFAC-3F1D-A029-BCA881D7CAA4}"/>
+                <a16:creationId xmlns:a16="http://schemas.microsoft.com/office/drawing/2014/main" id="{665EA9CF-C87C-B717-5214-EF0EB6892AD7}"/>
               </a:ext>
             </a:extLst>
           </p:cNvPr>
@@ -1451,7 +1451,7 @@
           <p:cNvPr id="4" name="コンテンツ プレースホルダー 3">
             <a:extLst>
               <a:ext uri="{FF2B5EF4-FFF2-40B4-BE49-F238E27FC236}">
-                <a16:creationId xmlns:a16="http://schemas.microsoft.com/office/drawing/2014/main" id="{9B9DE894-6C2F-D831-5A1C-E25CFC256B88}"/>
+                <a16:creationId xmlns:a16="http://schemas.microsoft.com/office/drawing/2014/main" id="{5EF3EE82-A86D-F9FA-E550-744EDD6856FC}"/>
               </a:ext>
             </a:extLst>
           </p:cNvPr>
@@ -1545,7 +1545,7 @@
           <p:cNvPr id="5" name="日付プレースホルダー 4">
             <a:extLst>
               <a:ext uri="{FF2B5EF4-FFF2-40B4-BE49-F238E27FC236}">
-                <a16:creationId xmlns:a16="http://schemas.microsoft.com/office/drawing/2014/main" id="{6F4CC2C0-4218-9757-C5EA-C9A5077F5A53}"/>
+                <a16:creationId xmlns:a16="http://schemas.microsoft.com/office/drawing/2014/main" id="{61FC15D1-F200-BD3A-E168-91DD2EF95B8B}"/>
               </a:ext>
             </a:extLst>
           </p:cNvPr>
@@ -1561,7 +1561,7 @@
           <a:bodyPr/>
           <a:lstStyle/>
           <a:p>
-            <a:fld id="{B6352141-9843-4316-BBDD-32833FECAE64}" type="datetimeFigureOut">
+            <a:fld id="{16C84519-D319-46E2-8FEF-E30A6544EB7B}" type="datetimeFigureOut">
               <a:rPr kumimoji="1" lang="ja-JP" altLang="en-US" smtClean="0"/>
               <a:t>2026/7/30</a:t>
             </a:fld>
@@ -1574,7 +1574,7 @@
           <p:cNvPr id="6" name="フッター プレースホルダー 5">
             <a:extLst>
               <a:ext uri="{FF2B5EF4-FFF2-40B4-BE49-F238E27FC236}">
-                <a16:creationId xmlns:a16="http://schemas.microsoft.com/office/drawing/2014/main" id="{3EAEC2FD-94D4-AD3E-9235-F3B734938EAF}"/>
+                <a16:creationId xmlns:a16="http://schemas.microsoft.com/office/drawing/2014/main" id="{7FFBC3E8-69C0-B1F7-7D03-A803ED5C17CE}"/>
               </a:ext>
             </a:extLst>
           </p:cNvPr>
@@ -1599,7 +1599,7 @@
           <p:cNvPr id="7" name="スライド番号プレースホルダー 6">
             <a:extLst>
               <a:ext uri="{FF2B5EF4-FFF2-40B4-BE49-F238E27FC236}">
-                <a16:creationId xmlns:a16="http://schemas.microsoft.com/office/drawing/2014/main" id="{4A4B86A4-908D-0416-5536-B29E8272E732}"/>
+                <a16:creationId xmlns:a16="http://schemas.microsoft.com/office/drawing/2014/main" id="{65077567-CEE6-515F-4AFE-FF2DE909C570}"/>
               </a:ext>
             </a:extLst>
           </p:cNvPr>
@@ -1615,7 +1615,7 @@
           <a:bodyPr/>
           <a:lstStyle/>
           <a:p>
-            <a:fld id="{2144295E-E99D-4840-ACBC-FAC7FF7804ED}" type="slidenum">
+            <a:fld id="{03EEC84A-F438-4B8D-8613-D1012426F156}" type="slidenum">
               <a:rPr kumimoji="1" lang="ja-JP" altLang="en-US" smtClean="0"/>
               <a:t>‹#›</a:t>
             </a:fld>
@@ -1626,7 +1626,7 @@
     </p:spTree>
     <p:extLst>
       <p:ext uri="{BB962C8B-B14F-4D97-AF65-F5344CB8AC3E}">
-        <p14:creationId xmlns:p14="http://schemas.microsoft.com/office/powerpoint/2010/main" val="1268028421"/>
+        <p14:creationId xmlns:p14="http://schemas.microsoft.com/office/powerpoint/2010/main" val="2603988455"/>
       </p:ext>
     </p:extLst>
   </p:cSld>
@@ -1658,7 +1658,7 @@
           <p:cNvPr id="2" name="タイトル 1">
             <a:extLst>
               <a:ext uri="{FF2B5EF4-FFF2-40B4-BE49-F238E27FC236}">
-                <a16:creationId xmlns:a16="http://schemas.microsoft.com/office/drawing/2014/main" id="{53D9619D-595A-1C06-848E-5EF70BE1ECB9}"/>
+                <a16:creationId xmlns:a16="http://schemas.microsoft.com/office/drawing/2014/main" id="{016AEB1C-8A54-DB09-DDA0-FCA2A6E5075F}"/>
               </a:ext>
             </a:extLst>
           </p:cNvPr>
@@ -1691,7 +1691,7 @@
           <p:cNvPr id="3" name="テキスト プレースホルダー 2">
             <a:extLst>
               <a:ext uri="{FF2B5EF4-FFF2-40B4-BE49-F238E27FC236}">
-                <a16:creationId xmlns:a16="http://schemas.microsoft.com/office/drawing/2014/main" id="{90D263B3-B13D-991D-3290-99E3935793F1}"/>
+                <a16:creationId xmlns:a16="http://schemas.microsoft.com/office/drawing/2014/main" id="{D61E69F0-77E1-13E4-84CB-18619D9D4F73}"/>
               </a:ext>
             </a:extLst>
           </p:cNvPr>
@@ -1762,7 +1762,7 @@
           <p:cNvPr id="4" name="コンテンツ プレースホルダー 3">
             <a:extLst>
               <a:ext uri="{FF2B5EF4-FFF2-40B4-BE49-F238E27FC236}">
-                <a16:creationId xmlns:a16="http://schemas.microsoft.com/office/drawing/2014/main" id="{18FDCE0B-F8CF-C2CC-22BC-A5DF1D229541}"/>
+                <a16:creationId xmlns:a16="http://schemas.microsoft.com/office/drawing/2014/main" id="{4E7AE8E5-DB9C-2ABF-D8DF-7B4E3A11BB79}"/>
               </a:ext>
             </a:extLst>
           </p:cNvPr>
@@ -1856,7 +1856,7 @@
           <p:cNvPr id="5" name="テキスト プレースホルダー 4">
             <a:extLst>
               <a:ext uri="{FF2B5EF4-FFF2-40B4-BE49-F238E27FC236}">
-                <a16:creationId xmlns:a16="http://schemas.microsoft.com/office/drawing/2014/main" id="{9F4E2720-25CE-349F-BB4C-642723B8EB58}"/>
+                <a16:creationId xmlns:a16="http://schemas.microsoft.com/office/drawing/2014/main" id="{4A1731E8-155A-C626-2FDD-E8B904B54846}"/>
               </a:ext>
             </a:extLst>
           </p:cNvPr>
@@ -1927,7 +1927,7 @@
           <p:cNvPr id="6" name="コンテンツ プレースホルダー 5">
             <a:extLst>
               <a:ext uri="{FF2B5EF4-FFF2-40B4-BE49-F238E27FC236}">
-                <a16:creationId xmlns:a16="http://schemas.microsoft.com/office/drawing/2014/main" id="{1D7B6476-22E3-26AC-608A-8B82983B424F}"/>
+                <a16:creationId xmlns:a16="http://schemas.microsoft.com/office/drawing/2014/main" id="{F14A3FA1-3597-0BC5-B8D4-375FE3BF9AB1}"/>
               </a:ext>
             </a:extLst>
           </p:cNvPr>
@@ -2021,7 +2021,7 @@
           <p:cNvPr id="7" name="日付プレースホルダー 6">
             <a:extLst>
               <a:ext uri="{FF2B5EF4-FFF2-40B4-BE49-F238E27FC236}">
-                <a16:creationId xmlns:a16="http://schemas.microsoft.com/office/drawing/2014/main" id="{6DE5D049-CBA3-5FF0-436E-AF1E5926A3B7}"/>
+                <a16:creationId xmlns:a16="http://schemas.microsoft.com/office/drawing/2014/main" id="{EB7F7025-F387-1AE5-C2F6-E8986E095176}"/>
               </a:ext>
             </a:extLst>
           </p:cNvPr>
@@ -2037,7 +2037,7 @@
           <a:bodyPr/>
           <a:lstStyle/>
           <a:p>
-            <a:fld id="{B6352141-9843-4316-BBDD-32833FECAE64}" type="datetimeFigureOut">
+            <a:fld id="{16C84519-D319-46E2-8FEF-E30A6544EB7B}" type="datetimeFigureOut">
               <a:rPr kumimoji="1" lang="ja-JP" altLang="en-US" smtClean="0"/>
               <a:t>2026/7/30</a:t>
             </a:fld>
@@ -2050,7 +2050,7 @@
           <p:cNvPr id="8" name="フッター プレースホルダー 7">
             <a:extLst>
               <a:ext uri="{FF2B5EF4-FFF2-40B4-BE49-F238E27FC236}">
-                <a16:creationId xmlns:a16="http://schemas.microsoft.com/office/drawing/2014/main" id="{F200D822-A535-8CC2-D039-253609BC330D}"/>
+                <a16:creationId xmlns:a16="http://schemas.microsoft.com/office/drawing/2014/main" id="{EB9C8726-D373-64AE-0530-575252A6AC8F}"/>
               </a:ext>
             </a:extLst>
           </p:cNvPr>
@@ -2075,7 +2075,7 @@
           <p:cNvPr id="9" name="スライド番号プレースホルダー 8">
             <a:extLst>
               <a:ext uri="{FF2B5EF4-FFF2-40B4-BE49-F238E27FC236}">
-                <a16:creationId xmlns:a16="http://schemas.microsoft.com/office/drawing/2014/main" id="{12336A89-56FC-88E1-88F1-B768348698A5}"/>
+                <a16:creationId xmlns:a16="http://schemas.microsoft.com/office/drawing/2014/main" id="{38E5004E-4325-AFBE-63AC-13C8D5DCBA73}"/>
               </a:ext>
             </a:extLst>
           </p:cNvPr>
@@ -2091,7 +2091,7 @@
           <a:bodyPr/>
           <a:lstStyle/>
           <a:p>
-            <a:fld id="{2144295E-E99D-4840-ACBC-FAC7FF7804ED}" type="slidenum">
+            <a:fld id="{03EEC84A-F438-4B8D-8613-D1012426F156}" type="slidenum">
               <a:rPr kumimoji="1" lang="ja-JP" altLang="en-US" smtClean="0"/>
               <a:t>‹#›</a:t>
             </a:fld>
@@ -2102,7 +2102,7 @@
     </p:spTree>
     <p:extLst>
       <p:ext uri="{BB962C8B-B14F-4D97-AF65-F5344CB8AC3E}">
-        <p14:creationId xmlns:p14="http://schemas.microsoft.com/office/powerpoint/2010/main" val="2448051448"/>
+        <p14:creationId xmlns:p14="http://schemas.microsoft.com/office/powerpoint/2010/main" val="1450667869"/>
       </p:ext>
     </p:extLst>
   </p:cSld>
@@ -2134,7 +2134,7 @@
           <p:cNvPr id="2" name="タイトル 1">
             <a:extLst>
               <a:ext uri="{FF2B5EF4-FFF2-40B4-BE49-F238E27FC236}">
-                <a16:creationId xmlns:a16="http://schemas.microsoft.com/office/drawing/2014/main" id="{644E5515-9406-B1F3-6239-B6FE78E932BB}"/>
+                <a16:creationId xmlns:a16="http://schemas.microsoft.com/office/drawing/2014/main" id="{B7E3A79F-AADD-6C9A-E366-75510D790865}"/>
               </a:ext>
             </a:extLst>
           </p:cNvPr>
@@ -2162,7 +2162,7 @@
           <p:cNvPr id="3" name="日付プレースホルダー 2">
             <a:extLst>
               <a:ext uri="{FF2B5EF4-FFF2-40B4-BE49-F238E27FC236}">
-                <a16:creationId xmlns:a16="http://schemas.microsoft.com/office/drawing/2014/main" id="{79734604-F7FD-CC27-88AA-9E6FA80F2278}"/>
+                <a16:creationId xmlns:a16="http://schemas.microsoft.com/office/drawing/2014/main" id="{7CF97A36-15CF-6A1E-2803-2BE4EC19D8D1}"/>
               </a:ext>
             </a:extLst>
           </p:cNvPr>
@@ -2178,7 +2178,7 @@
           <a:bodyPr/>
           <a:lstStyle/>
           <a:p>
-            <a:fld id="{B6352141-9843-4316-BBDD-32833FECAE64}" type="datetimeFigureOut">
+            <a:fld id="{16C84519-D319-46E2-8FEF-E30A6544EB7B}" type="datetimeFigureOut">
               <a:rPr kumimoji="1" lang="ja-JP" altLang="en-US" smtClean="0"/>
               <a:t>2026/7/30</a:t>
             </a:fld>
@@ -2191,7 +2191,7 @@
           <p:cNvPr id="4" name="フッター プレースホルダー 3">
             <a:extLst>
               <a:ext uri="{FF2B5EF4-FFF2-40B4-BE49-F238E27FC236}">
-                <a16:creationId xmlns:a16="http://schemas.microsoft.com/office/drawing/2014/main" id="{4DED54B2-82BC-389A-2533-2D5A31954897}"/>
+                <a16:creationId xmlns:a16="http://schemas.microsoft.com/office/drawing/2014/main" id="{6664E0AB-49BE-A858-22A1-9C7E452FD903}"/>
               </a:ext>
             </a:extLst>
           </p:cNvPr>
@@ -2216,7 +2216,7 @@
           <p:cNvPr id="5" name="スライド番号プレースホルダー 4">
             <a:extLst>
               <a:ext uri="{FF2B5EF4-FFF2-40B4-BE49-F238E27FC236}">
-                <a16:creationId xmlns:a16="http://schemas.microsoft.com/office/drawing/2014/main" id="{7E6882EA-8C5F-811E-BC7E-8E28CB097501}"/>
+                <a16:creationId xmlns:a16="http://schemas.microsoft.com/office/drawing/2014/main" id="{8EAED172-A0AB-6046-6C6D-8312FD728807}"/>
               </a:ext>
             </a:extLst>
           </p:cNvPr>
@@ -2232,7 +2232,7 @@
           <a:bodyPr/>
           <a:lstStyle/>
           <a:p>
-            <a:fld id="{2144295E-E99D-4840-ACBC-FAC7FF7804ED}" type="slidenum">
+            <a:fld id="{03EEC84A-F438-4B8D-8613-D1012426F156}" type="slidenum">
               <a:rPr kumimoji="1" lang="ja-JP" altLang="en-US" smtClean="0"/>
               <a:t>‹#›</a:t>
             </a:fld>
@@ -2243,7 +2243,7 @@
     </p:spTree>
     <p:extLst>
       <p:ext uri="{BB962C8B-B14F-4D97-AF65-F5344CB8AC3E}">
-        <p14:creationId xmlns:p14="http://schemas.microsoft.com/office/powerpoint/2010/main" val="3637694246"/>
+        <p14:creationId xmlns:p14="http://schemas.microsoft.com/office/powerpoint/2010/main" val="3171714851"/>
       </p:ext>
     </p:extLst>
   </p:cSld>
@@ -2275,7 +2275,7 @@
           <p:cNvPr id="2" name="日付プレースホルダー 1">
             <a:extLst>
               <a:ext uri="{FF2B5EF4-FFF2-40B4-BE49-F238E27FC236}">
-                <a16:creationId xmlns:a16="http://schemas.microsoft.com/office/drawing/2014/main" id="{90BFB796-B2E7-8246-5F44-4BEF0C28BCC4}"/>
+                <a16:creationId xmlns:a16="http://schemas.microsoft.com/office/drawing/2014/main" id="{2C18BECA-D8B3-8ADF-A35F-20B025840838}"/>
               </a:ext>
             </a:extLst>
           </p:cNvPr>
@@ -2291,7 +2291,7 @@
           <a:bodyPr/>
           <a:lstStyle/>
           <a:p>
-            <a:fld id="{B6352141-9843-4316-BBDD-32833FECAE64}" type="datetimeFigureOut">
+            <a:fld id="{16C84519-D319-46E2-8FEF-E30A6544EB7B}" type="datetimeFigureOut">
               <a:rPr kumimoji="1" lang="ja-JP" altLang="en-US" smtClean="0"/>
               <a:t>2026/7/30</a:t>
             </a:fld>
@@ -2304,7 +2304,7 @@
           <p:cNvPr id="3" name="フッター プレースホルダー 2">
             <a:extLst>
               <a:ext uri="{FF2B5EF4-FFF2-40B4-BE49-F238E27FC236}">
-                <a16:creationId xmlns:a16="http://schemas.microsoft.com/office/drawing/2014/main" id="{CE4D53E7-2AFF-B86D-A5E4-B2BBFDE3645C}"/>
+                <a16:creationId xmlns:a16="http://schemas.microsoft.com/office/drawing/2014/main" id="{77257133-FFA8-278D-2889-58DFD5E80439}"/>
               </a:ext>
             </a:extLst>
           </p:cNvPr>
@@ -2329,7 +2329,7 @@
           <p:cNvPr id="4" name="スライド番号プレースホルダー 3">
             <a:extLst>
               <a:ext uri="{FF2B5EF4-FFF2-40B4-BE49-F238E27FC236}">
-                <a16:creationId xmlns:a16="http://schemas.microsoft.com/office/drawing/2014/main" id="{9E39F0C5-BBF3-DE8D-06D9-E5F3F683950A}"/>
+                <a16:creationId xmlns:a16="http://schemas.microsoft.com/office/drawing/2014/main" id="{46D243F2-16CE-7FA6-ED00-44BE7ED30D00}"/>
               </a:ext>
             </a:extLst>
           </p:cNvPr>
@@ -2345,7 +2345,7 @@
           <a:bodyPr/>
           <a:lstStyle/>
           <a:p>
-            <a:fld id="{2144295E-E99D-4840-ACBC-FAC7FF7804ED}" type="slidenum">
+            <a:fld id="{03EEC84A-F438-4B8D-8613-D1012426F156}" type="slidenum">
               <a:rPr kumimoji="1" lang="ja-JP" altLang="en-US" smtClean="0"/>
               <a:t>‹#›</a:t>
             </a:fld>
@@ -2356,7 +2356,7 @@
     </p:spTree>
     <p:extLst>
       <p:ext uri="{BB962C8B-B14F-4D97-AF65-F5344CB8AC3E}">
-        <p14:creationId xmlns:p14="http://schemas.microsoft.com/office/powerpoint/2010/main" val="207203335"/>
+        <p14:creationId xmlns:p14="http://schemas.microsoft.com/office/powerpoint/2010/main" val="3802761933"/>
       </p:ext>
     </p:extLst>
   </p:cSld>
@@ -2388,7 +2388,7 @@
           <p:cNvPr id="2" name="タイトル 1">
             <a:extLst>
               <a:ext uri="{FF2B5EF4-FFF2-40B4-BE49-F238E27FC236}">
-                <a16:creationId xmlns:a16="http://schemas.microsoft.com/office/drawing/2014/main" id="{6AEBF077-EF9E-484D-67D9-837CC1449DC3}"/>
+                <a16:creationId xmlns:a16="http://schemas.microsoft.com/office/drawing/2014/main" id="{7CADF9FC-310D-0271-AFE4-5562DFA317EF}"/>
               </a:ext>
             </a:extLst>
           </p:cNvPr>
@@ -2425,7 +2425,7 @@
           <p:cNvPr id="3" name="コンテンツ プレースホルダー 2">
             <a:extLst>
               <a:ext uri="{FF2B5EF4-FFF2-40B4-BE49-F238E27FC236}">
-                <a16:creationId xmlns:a16="http://schemas.microsoft.com/office/drawing/2014/main" id="{0B6EE205-F581-EB49-0695-368C07FF7301}"/>
+                <a16:creationId xmlns:a16="http://schemas.microsoft.com/office/drawing/2014/main" id="{D316D3AF-29F6-5A98-F956-8623FDEEAC29}"/>
               </a:ext>
             </a:extLst>
           </p:cNvPr>
@@ -2547,7 +2547,7 @@
           <p:cNvPr id="4" name="テキスト プレースホルダー 3">
             <a:extLst>
               <a:ext uri="{FF2B5EF4-FFF2-40B4-BE49-F238E27FC236}">
-                <a16:creationId xmlns:a16="http://schemas.microsoft.com/office/drawing/2014/main" id="{AA110F5B-BA91-4E89-710A-6263A89D513C}"/>
+                <a16:creationId xmlns:a16="http://schemas.microsoft.com/office/drawing/2014/main" id="{2FFED94A-85FD-0624-7FE0-A2B654717463}"/>
               </a:ext>
             </a:extLst>
           </p:cNvPr>
@@ -2618,7 +2618,7 @@
           <p:cNvPr id="5" name="日付プレースホルダー 4">
             <a:extLst>
               <a:ext uri="{FF2B5EF4-FFF2-40B4-BE49-F238E27FC236}">
-                <a16:creationId xmlns:a16="http://schemas.microsoft.com/office/drawing/2014/main" id="{4B3DC30E-8D11-019F-88F5-41A59D6FCC86}"/>
+                <a16:creationId xmlns:a16="http://schemas.microsoft.com/office/drawing/2014/main" id="{D6DB75F0-D159-2608-6CC1-A6BF7094B06D}"/>
               </a:ext>
             </a:extLst>
           </p:cNvPr>
@@ -2634,7 +2634,7 @@
           <a:bodyPr/>
           <a:lstStyle/>
           <a:p>
-            <a:fld id="{B6352141-9843-4316-BBDD-32833FECAE64}" type="datetimeFigureOut">
+            <a:fld id="{16C84519-D319-46E2-8FEF-E30A6544EB7B}" type="datetimeFigureOut">
               <a:rPr kumimoji="1" lang="ja-JP" altLang="en-US" smtClean="0"/>
               <a:t>2026/7/30</a:t>
             </a:fld>
@@ -2647,7 +2647,7 @@
           <p:cNvPr id="6" name="フッター プレースホルダー 5">
             <a:extLst>
               <a:ext uri="{FF2B5EF4-FFF2-40B4-BE49-F238E27FC236}">
-                <a16:creationId xmlns:a16="http://schemas.microsoft.com/office/drawing/2014/main" id="{DBA4234D-7973-4701-96A3-AFD93B1CC277}"/>
+                <a16:creationId xmlns:a16="http://schemas.microsoft.com/office/drawing/2014/main" id="{F9926F3E-6894-6077-3614-7999B1B61EEF}"/>
               </a:ext>
             </a:extLst>
           </p:cNvPr>
@@ -2672,7 +2672,7 @@
           <p:cNvPr id="7" name="スライド番号プレースホルダー 6">
             <a:extLst>
               <a:ext uri="{FF2B5EF4-FFF2-40B4-BE49-F238E27FC236}">
-                <a16:creationId xmlns:a16="http://schemas.microsoft.com/office/drawing/2014/main" id="{814C311F-512B-12CD-7396-5E0CFCDD473F}"/>
+                <a16:creationId xmlns:a16="http://schemas.microsoft.com/office/drawing/2014/main" id="{D3BE9D4E-985E-A1A0-B2A1-EDBB22A4DC55}"/>
               </a:ext>
             </a:extLst>
           </p:cNvPr>
@@ -2688,7 +2688,7 @@
           <a:bodyPr/>
           <a:lstStyle/>
           <a:p>
-            <a:fld id="{2144295E-E99D-4840-ACBC-FAC7FF7804ED}" type="slidenum">
+            <a:fld id="{03EEC84A-F438-4B8D-8613-D1012426F156}" type="slidenum">
               <a:rPr kumimoji="1" lang="ja-JP" altLang="en-US" smtClean="0"/>
               <a:t>‹#›</a:t>
             </a:fld>
@@ -2699,7 +2699,7 @@
     </p:spTree>
     <p:extLst>
       <p:ext uri="{BB962C8B-B14F-4D97-AF65-F5344CB8AC3E}">
-        <p14:creationId xmlns:p14="http://schemas.microsoft.com/office/powerpoint/2010/main" val="249593031"/>
+        <p14:creationId xmlns:p14="http://schemas.microsoft.com/office/powerpoint/2010/main" val="1800624658"/>
       </p:ext>
     </p:extLst>
   </p:cSld>
@@ -2731,7 +2731,7 @@
           <p:cNvPr id="2" name="タイトル 1">
             <a:extLst>
               <a:ext uri="{FF2B5EF4-FFF2-40B4-BE49-F238E27FC236}">
-                <a16:creationId xmlns:a16="http://schemas.microsoft.com/office/drawing/2014/main" id="{B705320E-6498-A2A2-C818-E66BAB99D9CB}"/>
+                <a16:creationId xmlns:a16="http://schemas.microsoft.com/office/drawing/2014/main" id="{03379F74-D9DB-375F-8616-16ACB3F8004E}"/>
               </a:ext>
             </a:extLst>
           </p:cNvPr>
@@ -2768,7 +2768,7 @@
           <p:cNvPr id="3" name="図プレースホルダー 2">
             <a:extLst>
               <a:ext uri="{FF2B5EF4-FFF2-40B4-BE49-F238E27FC236}">
-                <a16:creationId xmlns:a16="http://schemas.microsoft.com/office/drawing/2014/main" id="{E7BDE621-1F03-C2EF-A2DE-E042AEE69EE5}"/>
+                <a16:creationId xmlns:a16="http://schemas.microsoft.com/office/drawing/2014/main" id="{36C8F592-6404-6440-5B2A-9F1A3ED80113}"/>
               </a:ext>
             </a:extLst>
           </p:cNvPr>
@@ -2835,7 +2835,7 @@
           <p:cNvPr id="4" name="テキスト プレースホルダー 3">
             <a:extLst>
               <a:ext uri="{FF2B5EF4-FFF2-40B4-BE49-F238E27FC236}">
-                <a16:creationId xmlns:a16="http://schemas.microsoft.com/office/drawing/2014/main" id="{337EB4AB-E15A-0528-8903-0999D906C7E2}"/>
+                <a16:creationId xmlns:a16="http://schemas.microsoft.com/office/drawing/2014/main" id="{833850E0-E0CF-072F-39C5-155ED9C5C3CB}"/>
               </a:ext>
             </a:extLst>
           </p:cNvPr>
@@ -2906,7 +2906,7 @@
           <p:cNvPr id="5" name="日付プレースホルダー 4">
             <a:extLst>
               <a:ext uri="{FF2B5EF4-FFF2-40B4-BE49-F238E27FC236}">
-                <a16:creationId xmlns:a16="http://schemas.microsoft.com/office/drawing/2014/main" id="{F45705B6-F7A4-EF95-B4D4-B5C7BF30E659}"/>
+                <a16:creationId xmlns:a16="http://schemas.microsoft.com/office/drawing/2014/main" id="{9064C5F4-B3F5-8EA6-9EF9-0717A85E4D19}"/>
               </a:ext>
             </a:extLst>
           </p:cNvPr>
@@ -2922,7 +2922,7 @@
           <a:bodyPr/>
           <a:lstStyle/>
           <a:p>
-            <a:fld id="{B6352141-9843-4316-BBDD-32833FECAE64}" type="datetimeFigureOut">
+            <a:fld id="{16C84519-D319-46E2-8FEF-E30A6544EB7B}" type="datetimeFigureOut">
               <a:rPr kumimoji="1" lang="ja-JP" altLang="en-US" smtClean="0"/>
               <a:t>2026/7/30</a:t>
             </a:fld>
@@ -2935,7 +2935,7 @@
           <p:cNvPr id="6" name="フッター プレースホルダー 5">
             <a:extLst>
               <a:ext uri="{FF2B5EF4-FFF2-40B4-BE49-F238E27FC236}">
-                <a16:creationId xmlns:a16="http://schemas.microsoft.com/office/drawing/2014/main" id="{B91C328C-016C-7550-E538-860074E63A83}"/>
+                <a16:creationId xmlns:a16="http://schemas.microsoft.com/office/drawing/2014/main" id="{800B6F30-C058-719D-24B5-1FAF5BC76F95}"/>
               </a:ext>
             </a:extLst>
           </p:cNvPr>
@@ -2960,7 +2960,7 @@
           <p:cNvPr id="7" name="スライド番号プレースホルダー 6">
             <a:extLst>
               <a:ext uri="{FF2B5EF4-FFF2-40B4-BE49-F238E27FC236}">
-                <a16:creationId xmlns:a16="http://schemas.microsoft.com/office/drawing/2014/main" id="{A3615B20-D1CD-BC9C-748D-0AFD7A508824}"/>
+                <a16:creationId xmlns:a16="http://schemas.microsoft.com/office/drawing/2014/main" id="{BA34E8AF-6F49-98A8-2A92-2F3DBA01D11D}"/>
               </a:ext>
             </a:extLst>
           </p:cNvPr>
@@ -2976,7 +2976,7 @@
           <a:bodyPr/>
           <a:lstStyle/>
           <a:p>
-            <a:fld id="{2144295E-E99D-4840-ACBC-FAC7FF7804ED}" type="slidenum">
+            <a:fld id="{03EEC84A-F438-4B8D-8613-D1012426F156}" type="slidenum">
               <a:rPr kumimoji="1" lang="ja-JP" altLang="en-US" smtClean="0"/>
               <a:t>‹#›</a:t>
             </a:fld>
@@ -2987,7 +2987,7 @@
     </p:spTree>
     <p:extLst>
       <p:ext uri="{BB962C8B-B14F-4D97-AF65-F5344CB8AC3E}">
-        <p14:creationId xmlns:p14="http://schemas.microsoft.com/office/powerpoint/2010/main" val="1966884577"/>
+        <p14:creationId xmlns:p14="http://schemas.microsoft.com/office/powerpoint/2010/main" val="769074834"/>
       </p:ext>
     </p:extLst>
   </p:cSld>
@@ -3024,7 +3024,7 @@
           <p:cNvPr id="2" name="タイトル プレースホルダー 1">
             <a:extLst>
               <a:ext uri="{FF2B5EF4-FFF2-40B4-BE49-F238E27FC236}">
-                <a16:creationId xmlns:a16="http://schemas.microsoft.com/office/drawing/2014/main" id="{9FD26FBA-4642-8D70-0207-40B22118F05E}"/>
+                <a16:creationId xmlns:a16="http://schemas.microsoft.com/office/drawing/2014/main" id="{7C6A479F-2D0A-CE5A-F3B3-5FC777535296}"/>
               </a:ext>
             </a:extLst>
           </p:cNvPr>
@@ -3062,7 +3062,7 @@
           <p:cNvPr id="3" name="テキスト プレースホルダー 2">
             <a:extLst>
               <a:ext uri="{FF2B5EF4-FFF2-40B4-BE49-F238E27FC236}">
-                <a16:creationId xmlns:a16="http://schemas.microsoft.com/office/drawing/2014/main" id="{0594F96E-4F5D-559D-412F-F4252652C714}"/>
+                <a16:creationId xmlns:a16="http://schemas.microsoft.com/office/drawing/2014/main" id="{1CB5887A-3B02-C11E-9305-CEE1F40D0C72}"/>
               </a:ext>
             </a:extLst>
           </p:cNvPr>
@@ -3161,7 +3161,7 @@
           <p:cNvPr id="4" name="日付プレースホルダー 3">
             <a:extLst>
               <a:ext uri="{FF2B5EF4-FFF2-40B4-BE49-F238E27FC236}">
-                <a16:creationId xmlns:a16="http://schemas.microsoft.com/office/drawing/2014/main" id="{E09A1924-47D9-2FE2-E66C-A7129F482C92}"/>
+                <a16:creationId xmlns:a16="http://schemas.microsoft.com/office/drawing/2014/main" id="{369B544C-1545-5EFB-4533-39846A7975BB}"/>
               </a:ext>
             </a:extLst>
           </p:cNvPr>
@@ -3195,7 +3195,7 @@
             </a:lvl1pPr>
           </a:lstStyle>
           <a:p>
-            <a:fld id="{B6352141-9843-4316-BBDD-32833FECAE64}" type="datetimeFigureOut">
+            <a:fld id="{16C84519-D319-46E2-8FEF-E30A6544EB7B}" type="datetimeFigureOut">
               <a:rPr kumimoji="1" lang="ja-JP" altLang="en-US" smtClean="0"/>
               <a:t>2026/7/30</a:t>
             </a:fld>
@@ -3208,7 +3208,7 @@
           <p:cNvPr id="5" name="フッター プレースホルダー 4">
             <a:extLst>
               <a:ext uri="{FF2B5EF4-FFF2-40B4-BE49-F238E27FC236}">
-                <a16:creationId xmlns:a16="http://schemas.microsoft.com/office/drawing/2014/main" id="{206143CF-BDD2-ABF3-D764-A2ABA763A17B}"/>
+                <a16:creationId xmlns:a16="http://schemas.microsoft.com/office/drawing/2014/main" id="{F3887A70-FDD5-F97D-0357-0A62781FFF48}"/>
               </a:ext>
             </a:extLst>
           </p:cNvPr>
@@ -3251,7 +3251,7 @@
           <p:cNvPr id="6" name="スライド番号プレースホルダー 5">
             <a:extLst>
               <a:ext uri="{FF2B5EF4-FFF2-40B4-BE49-F238E27FC236}">
-                <a16:creationId xmlns:a16="http://schemas.microsoft.com/office/drawing/2014/main" id="{F21AA136-C23D-99FC-B916-5315D937DB21}"/>
+                <a16:creationId xmlns:a16="http://schemas.microsoft.com/office/drawing/2014/main" id="{DF7A801B-D684-576F-A3C3-7B7F367A24A9}"/>
               </a:ext>
             </a:extLst>
           </p:cNvPr>
@@ -3285,7 +3285,7 @@
             </a:lvl1pPr>
           </a:lstStyle>
           <a:p>
-            <a:fld id="{2144295E-E99D-4840-ACBC-FAC7FF7804ED}" type="slidenum">
+            <a:fld id="{03EEC84A-F438-4B8D-8613-D1012426F156}" type="slidenum">
               <a:rPr kumimoji="1" lang="ja-JP" altLang="en-US" smtClean="0"/>
               <a:t>‹#›</a:t>
             </a:fld>
@@ -3296,7 +3296,7 @@
     </p:spTree>
     <p:extLst>
       <p:ext uri="{BB962C8B-B14F-4D97-AF65-F5344CB8AC3E}">
-        <p14:creationId xmlns:p14="http://schemas.microsoft.com/office/powerpoint/2010/main" val="2310460853"/>
+        <p14:creationId xmlns:p14="http://schemas.microsoft.com/office/powerpoint/2010/main" val="3552560961"/>
       </p:ext>
     </p:extLst>
   </p:cSld>
@@ -3619,7 +3619,7 @@
           <p:cNvPr id="2" name="テキスト ボックス 1">
             <a:extLst>
               <a:ext uri="{FF2B5EF4-FFF2-40B4-BE49-F238E27FC236}">
-                <a16:creationId xmlns:a16="http://schemas.microsoft.com/office/drawing/2014/main" id="{DAC3CF4D-B021-4378-83CB-21B3D003A9C1}"/>
+                <a16:creationId xmlns:a16="http://schemas.microsoft.com/office/drawing/2014/main" id="{19860262-723E-6196-9034-91C507FA2A82}"/>
               </a:ext>
             </a:extLst>
           </p:cNvPr>
@@ -3665,7 +3665,7 @@
           <p:cNvPr id="3" name="テキスト ボックス 2">
             <a:extLst>
               <a:ext uri="{FF2B5EF4-FFF2-40B4-BE49-F238E27FC236}">
-                <a16:creationId xmlns:a16="http://schemas.microsoft.com/office/drawing/2014/main" id="{084E4627-2633-10FC-09E7-98E9A758B7D7}"/>
+                <a16:creationId xmlns:a16="http://schemas.microsoft.com/office/drawing/2014/main" id="{0E64A10B-FA5F-ACCC-810C-DE2DC5CC6F75}"/>
               </a:ext>
             </a:extLst>
           </p:cNvPr>
@@ -3695,14 +3695,17 @@
                 </a:solidFill>
                 <a:latin typeface="Arial" panose="020B0604020202020204" pitchFamily="34" charset="0"/>
               </a:rPr>
-              <a:t>akecom-spa2x-ryu TECH EXPLANATION</a:t>
-            </a:r>
-            <a:endParaRPr kumimoji="1" lang="ja-JP" altLang="en-US" sz="3400" b="1">
-              <a:solidFill>
-                <a:srgbClr val="111111"/>
-              </a:solidFill>
-              <a:latin typeface="Arial" panose="020B0604020202020204" pitchFamily="34" charset="0"/>
-            </a:endParaRPr>
+              <a:t>Akecom Spa2x Ryu</a:t>
+            </a:r>
+            <a:r>
+              <a:rPr kumimoji="1" lang="ja-JP" altLang="en-US" sz="3400" b="1">
+                <a:solidFill>
+                  <a:srgbClr val="111111"/>
+                </a:solidFill>
+                <a:latin typeface="Arial" panose="020B0604020202020204" pitchFamily="34" charset="0"/>
+              </a:rPr>
+              <a:t>の技術解説</a:t>
+            </a:r>
           </a:p>
         </p:txBody>
       </p:sp>
@@ -3711,7 +3714,7 @@
           <p:cNvPr id="4" name="テキスト ボックス 3">
             <a:extLst>
               <a:ext uri="{FF2B5EF4-FFF2-40B4-BE49-F238E27FC236}">
-                <a16:creationId xmlns:a16="http://schemas.microsoft.com/office/drawing/2014/main" id="{BF96908F-77B9-DC11-5408-7ACE1F393B69}"/>
+                <a16:creationId xmlns:a16="http://schemas.microsoft.com/office/drawing/2014/main" id="{7FA4129D-84A1-1C55-3620-EDB932D180E7}"/>
               </a:ext>
             </a:extLst>
           </p:cNvPr>
@@ -3735,20 +3738,14 @@
           <a:lstStyle/>
           <a:p>
             <a:r>
-              <a:rPr kumimoji="1" lang="en-US" altLang="ja-JP" sz="2000">
+              <a:rPr kumimoji="1" lang="ja-JP" altLang="en-US" sz="2000">
                 <a:solidFill>
                   <a:srgbClr val="333333"/>
                 </a:solidFill>
                 <a:latin typeface="Arial" panose="020B0604020202020204" pitchFamily="34" charset="0"/>
               </a:rPr>
-              <a:t>Architecture, implementation and commit history in 75 seconds</a:t>
-            </a:r>
-            <a:endParaRPr kumimoji="1" lang="ja-JP" altLang="en-US" sz="2000">
-              <a:solidFill>
-                <a:srgbClr val="333333"/>
-              </a:solidFill>
-              <a:latin typeface="Arial" panose="020B0604020202020204" pitchFamily="34" charset="0"/>
-            </a:endParaRPr>
+              <a:t>設計・実装・コミットから学ぶ短時間プレビュー</a:t>
+            </a:r>
           </a:p>
         </p:txBody>
       </p:sp>
@@ -3757,7 +3754,7 @@
           <p:cNvPr id="5" name="テキスト ボックス 4">
             <a:extLst>
               <a:ext uri="{FF2B5EF4-FFF2-40B4-BE49-F238E27FC236}">
-                <a16:creationId xmlns:a16="http://schemas.microsoft.com/office/drawing/2014/main" id="{7F750933-EE11-0D25-7AEE-8BA4F2D8C412}"/>
+                <a16:creationId xmlns:a16="http://schemas.microsoft.com/office/drawing/2014/main" id="{BF7BF896-1738-3EC8-F11A-4A197AA06C5F}"/>
               </a:ext>
             </a:extLst>
           </p:cNvPr>
@@ -3804,7 +3801,7 @@
             <a:hlinkClick r:id="" action="ppaction://media"/>
             <a:extLst>
               <a:ext uri="{FF2B5EF4-FFF2-40B4-BE49-F238E27FC236}">
-                <a16:creationId xmlns:a16="http://schemas.microsoft.com/office/drawing/2014/main" id="{2F9CACBA-1A72-2BE4-EF6D-EA0FB6D5784C}"/>
+                <a16:creationId xmlns:a16="http://schemas.microsoft.com/office/drawing/2014/main" id="{0B2C88E0-12A9-ED48-687D-FDC3D0917E27}"/>
               </a:ext>
             </a:extLst>
           </p:cNvPr>
@@ -3839,7 +3836,7 @@
     </p:spTree>
     <p:extLst>
       <p:ext uri="{BB962C8B-B14F-4D97-AF65-F5344CB8AC3E}">
-        <p14:creationId xmlns:p14="http://schemas.microsoft.com/office/powerpoint/2010/main" val="2123226984"/>
+        <p14:creationId xmlns:p14="http://schemas.microsoft.com/office/powerpoint/2010/main" val="2150669080"/>
       </p:ext>
     </p:extLst>
   </p:cSld>
@@ -3963,7 +3960,7 @@
           <p:cNvPr id="2" name="テキスト ボックス 1">
             <a:extLst>
               <a:ext uri="{FF2B5EF4-FFF2-40B4-BE49-F238E27FC236}">
-                <a16:creationId xmlns:a16="http://schemas.microsoft.com/office/drawing/2014/main" id="{093018C5-6739-E96D-CA86-A4AEF9F05C66}"/>
+                <a16:creationId xmlns:a16="http://schemas.microsoft.com/office/drawing/2014/main" id="{9E504348-C379-7621-B566-1079A39785A5}"/>
               </a:ext>
             </a:extLst>
           </p:cNvPr>
@@ -4009,7 +4006,7 @@
           <p:cNvPr id="3" name="テキスト ボックス 2">
             <a:extLst>
               <a:ext uri="{FF2B5EF4-FFF2-40B4-BE49-F238E27FC236}">
-                <a16:creationId xmlns:a16="http://schemas.microsoft.com/office/drawing/2014/main" id="{79FCFA53-DB98-FD78-FD20-60F272EA9F92}"/>
+                <a16:creationId xmlns:a16="http://schemas.microsoft.com/office/drawing/2014/main" id="{F050B14D-E167-A806-C109-D26891E069E8}"/>
               </a:ext>
             </a:extLst>
           </p:cNvPr>
@@ -4033,20 +4030,14 @@
           <a:lstStyle/>
           <a:p>
             <a:r>
-              <a:rPr kumimoji="1" lang="en-US" altLang="ja-JP" sz="3400" b="1">
+              <a:rPr kumimoji="1" lang="ja-JP" altLang="en-US" sz="3400" b="1">
                 <a:solidFill>
                   <a:srgbClr val="111111"/>
                 </a:solidFill>
                 <a:latin typeface="Arial" panose="020B0604020202020204" pitchFamily="34" charset="0"/>
               </a:rPr>
-              <a:t>WHAT DOES IT SOLVE?</a:t>
-            </a:r>
-            <a:endParaRPr kumimoji="1" lang="ja-JP" altLang="en-US" sz="3400" b="1">
-              <a:solidFill>
-                <a:srgbClr val="111111"/>
-              </a:solidFill>
-              <a:latin typeface="Arial" panose="020B0604020202020204" pitchFamily="34" charset="0"/>
-            </a:endParaRPr>
+              <a:t>このプロジェクトは何を解決する？</a:t>
+            </a:r>
           </a:p>
         </p:txBody>
       </p:sp>
@@ -4055,7 +4046,7 @@
           <p:cNvPr id="4" name="テキスト ボックス 3">
             <a:extLst>
               <a:ext uri="{FF2B5EF4-FFF2-40B4-BE49-F238E27FC236}">
-                <a16:creationId xmlns:a16="http://schemas.microsoft.com/office/drawing/2014/main" id="{9FE4B0F8-20FC-93D7-E54B-5DB1533D784A}"/>
+                <a16:creationId xmlns:a16="http://schemas.microsoft.com/office/drawing/2014/main" id="{BC7C3513-A49A-BE61-40C1-98D0A6DC3B52}"/>
               </a:ext>
             </a:extLst>
           </p:cNvPr>
@@ -4131,7 +4122,7 @@
           <p:cNvPr id="5" name="テキスト ボックス 4">
             <a:extLst>
               <a:ext uri="{FF2B5EF4-FFF2-40B4-BE49-F238E27FC236}">
-                <a16:creationId xmlns:a16="http://schemas.microsoft.com/office/drawing/2014/main" id="{39A678FD-6474-359D-8460-59ADC52F163C}"/>
+                <a16:creationId xmlns:a16="http://schemas.microsoft.com/office/drawing/2014/main" id="{15B14676-AB4B-BE24-499C-10818BA7AA31}"/>
               </a:ext>
             </a:extLst>
           </p:cNvPr>
@@ -4178,7 +4169,7 @@
             <a:hlinkClick r:id="" action="ppaction://media"/>
             <a:extLst>
               <a:ext uri="{FF2B5EF4-FFF2-40B4-BE49-F238E27FC236}">
-                <a16:creationId xmlns:a16="http://schemas.microsoft.com/office/drawing/2014/main" id="{EEC96012-5CEF-E9FF-B534-FEE1C1F3DD1F}"/>
+                <a16:creationId xmlns:a16="http://schemas.microsoft.com/office/drawing/2014/main" id="{365F099C-0E5E-7C33-5842-488C3C37CA8D}"/>
               </a:ext>
             </a:extLst>
           </p:cNvPr>
@@ -4213,7 +4204,7 @@
     </p:spTree>
     <p:extLst>
       <p:ext uri="{BB962C8B-B14F-4D97-AF65-F5344CB8AC3E}">
-        <p14:creationId xmlns:p14="http://schemas.microsoft.com/office/powerpoint/2010/main" val="2696612200"/>
+        <p14:creationId xmlns:p14="http://schemas.microsoft.com/office/powerpoint/2010/main" val="1613918112"/>
       </p:ext>
     </p:extLst>
   </p:cSld>
@@ -4337,7 +4328,7 @@
           <p:cNvPr id="2" name="テキスト ボックス 1">
             <a:extLst>
               <a:ext uri="{FF2B5EF4-FFF2-40B4-BE49-F238E27FC236}">
-                <a16:creationId xmlns:a16="http://schemas.microsoft.com/office/drawing/2014/main" id="{7F5D972C-EE28-5FB0-E58E-AEA843F5DFFD}"/>
+                <a16:creationId xmlns:a16="http://schemas.microsoft.com/office/drawing/2014/main" id="{2F34D9CB-38C1-0319-FEB0-68CAFA48E432}"/>
               </a:ext>
             </a:extLst>
           </p:cNvPr>
@@ -4383,7 +4374,7 @@
           <p:cNvPr id="3" name="テキスト ボックス 2">
             <a:extLst>
               <a:ext uri="{FF2B5EF4-FFF2-40B4-BE49-F238E27FC236}">
-                <a16:creationId xmlns:a16="http://schemas.microsoft.com/office/drawing/2014/main" id="{99C9DF38-E1DD-1D13-C4A9-F4B42439F37F}"/>
+                <a16:creationId xmlns:a16="http://schemas.microsoft.com/office/drawing/2014/main" id="{29E6B313-A45C-64C1-7233-DD411C254A80}"/>
               </a:ext>
             </a:extLst>
           </p:cNvPr>
@@ -4407,20 +4398,14 @@
           <a:lstStyle/>
           <a:p>
             <a:r>
-              <a:rPr kumimoji="1" lang="en-US" altLang="ja-JP" sz="3400" b="1">
+              <a:rPr kumimoji="1" lang="ja-JP" altLang="en-US" sz="3400" b="1">
                 <a:solidFill>
                   <a:srgbClr val="111111"/>
                 </a:solidFill>
                 <a:latin typeface="Arial" panose="020B0604020202020204" pitchFamily="34" charset="0"/>
               </a:rPr>
-              <a:t>TECH STACK</a:t>
-            </a:r>
-            <a:endParaRPr kumimoji="1" lang="ja-JP" altLang="en-US" sz="3400" b="1">
-              <a:solidFill>
-                <a:srgbClr val="111111"/>
-              </a:solidFill>
-              <a:latin typeface="Arial" panose="020B0604020202020204" pitchFamily="34" charset="0"/>
-            </a:endParaRPr>
+              <a:t>技術スタック</a:t>
+            </a:r>
           </a:p>
         </p:txBody>
       </p:sp>
@@ -4429,7 +4414,7 @@
           <p:cNvPr id="4" name="テキスト ボックス 3">
             <a:extLst>
               <a:ext uri="{FF2B5EF4-FFF2-40B4-BE49-F238E27FC236}">
-                <a16:creationId xmlns:a16="http://schemas.microsoft.com/office/drawing/2014/main" id="{741CE214-582F-60A2-723A-E830EBE73DA6}"/>
+                <a16:creationId xmlns:a16="http://schemas.microsoft.com/office/drawing/2014/main" id="{074C5B03-537D-2F2F-386F-88B738D0DC1D}"/>
               </a:ext>
             </a:extLst>
           </p:cNvPr>
@@ -4439,7 +4424,7 @@
         <p:spPr>
           <a:xfrm>
             <a:off x="533400" y="3429000"/>
-            <a:ext cx="10795000" cy="400110"/>
+            <a:ext cx="10795000" cy="707886"/>
           </a:xfrm>
           <a:prstGeom prst="rect">
             <a:avLst/>
@@ -4453,13 +4438,22 @@
           <a:lstStyle/>
           <a:p>
             <a:r>
+              <a:rPr kumimoji="1" lang="ja-JP" altLang="en-US" sz="2000">
+                <a:solidFill>
+                  <a:srgbClr val="333333"/>
+                </a:solidFill>
+                <a:latin typeface="Arial" panose="020B0604020202020204" pitchFamily="34" charset="0"/>
+              </a:rPr>
+              <a:t>主要技術：</a:t>
+            </a:r>
+            <a:r>
               <a:rPr kumimoji="1" lang="en-US" altLang="ja-JP" sz="2000">
                 <a:solidFill>
                   <a:srgbClr val="333333"/>
                 </a:solidFill>
                 <a:latin typeface="Arial" panose="020B0604020202020204" pitchFamily="34" charset="0"/>
               </a:rPr>
-              <a:t>Primary technologies: JavaScript</a:t>
+              <a:t>JavaScript</a:t>
             </a:r>
             <a:r>
               <a:rPr kumimoji="1" lang="ja-JP" altLang="en-US" sz="2000">
@@ -4495,14 +4489,18 @@
                 </a:solidFill>
                 <a:latin typeface="Arial" panose="020B0604020202020204" pitchFamily="34" charset="0"/>
               </a:rPr>
-              <a:t>HTML</a:t>
-            </a:r>
-            <a:endParaRPr kumimoji="1" lang="ja-JP" altLang="en-US" sz="2000">
-              <a:solidFill>
-                <a:srgbClr val="333333"/>
-              </a:solidFill>
-              <a:latin typeface="Arial" panose="020B0604020202020204" pitchFamily="34" charset="0"/>
-            </a:endParaRPr>
+              <a:t>HTML
+</a:t>
+            </a:r>
+            <a:r>
+              <a:rPr kumimoji="1" lang="ja-JP" altLang="en-US" sz="2000">
+                <a:solidFill>
+                  <a:srgbClr val="333333"/>
+                </a:solidFill>
+                <a:latin typeface="Arial" panose="020B0604020202020204" pitchFamily="34" charset="0"/>
+              </a:rPr>
+              <a:t>役割を分け、保守しやすい構成を目指しています。</a:t>
+            </a:r>
           </a:p>
         </p:txBody>
       </p:sp>
@@ -4511,7 +4509,7 @@
           <p:cNvPr id="5" name="テキスト ボックス 4">
             <a:extLst>
               <a:ext uri="{FF2B5EF4-FFF2-40B4-BE49-F238E27FC236}">
-                <a16:creationId xmlns:a16="http://schemas.microsoft.com/office/drawing/2014/main" id="{4426832B-FC3E-F508-2901-C3CAFF770323}"/>
+                <a16:creationId xmlns:a16="http://schemas.microsoft.com/office/drawing/2014/main" id="{97F470B9-783F-473F-EB9D-776B369489C4}"/>
               </a:ext>
             </a:extLst>
           </p:cNvPr>
@@ -4558,7 +4556,7 @@
             <a:hlinkClick r:id="" action="ppaction://media"/>
             <a:extLst>
               <a:ext uri="{FF2B5EF4-FFF2-40B4-BE49-F238E27FC236}">
-                <a16:creationId xmlns:a16="http://schemas.microsoft.com/office/drawing/2014/main" id="{6E2B36AA-BDCE-C03C-7DA0-675E05CFBB6B}"/>
+                <a16:creationId xmlns:a16="http://schemas.microsoft.com/office/drawing/2014/main" id="{7D6AB8A1-87DB-48BA-C51D-70BCFDD253C1}"/>
               </a:ext>
             </a:extLst>
           </p:cNvPr>
@@ -4593,7 +4591,7 @@
     </p:spTree>
     <p:extLst>
       <p:ext uri="{BB962C8B-B14F-4D97-AF65-F5344CB8AC3E}">
-        <p14:creationId xmlns:p14="http://schemas.microsoft.com/office/powerpoint/2010/main" val="509660644"/>
+        <p14:creationId xmlns:p14="http://schemas.microsoft.com/office/powerpoint/2010/main" val="663069947"/>
       </p:ext>
     </p:extLst>
   </p:cSld>
@@ -4717,7 +4715,7 @@
           <p:cNvPr id="2" name="テキスト ボックス 1">
             <a:extLst>
               <a:ext uri="{FF2B5EF4-FFF2-40B4-BE49-F238E27FC236}">
-                <a16:creationId xmlns:a16="http://schemas.microsoft.com/office/drawing/2014/main" id="{F1361BB5-C855-4CD1-EA87-6B2E9847A1DB}"/>
+                <a16:creationId xmlns:a16="http://schemas.microsoft.com/office/drawing/2014/main" id="{3EF342F4-2264-B849-D48C-59EB6B161DEB}"/>
               </a:ext>
             </a:extLst>
           </p:cNvPr>
@@ -4763,7 +4761,7 @@
           <p:cNvPr id="3" name="テキスト ボックス 2">
             <a:extLst>
               <a:ext uri="{FF2B5EF4-FFF2-40B4-BE49-F238E27FC236}">
-                <a16:creationId xmlns:a16="http://schemas.microsoft.com/office/drawing/2014/main" id="{95749355-12AB-A071-CF64-371B77BFC5E8}"/>
+                <a16:creationId xmlns:a16="http://schemas.microsoft.com/office/drawing/2014/main" id="{ABE315AC-AAAB-34B8-FADB-8CDFC663CD94}"/>
               </a:ext>
             </a:extLst>
           </p:cNvPr>
@@ -4787,20 +4785,14 @@
           <a:lstStyle/>
           <a:p>
             <a:r>
-              <a:rPr kumimoji="1" lang="en-US" altLang="ja-JP" sz="3400" b="1">
+              <a:rPr kumimoji="1" lang="ja-JP" altLang="en-US" sz="3400" b="1">
                 <a:solidFill>
                   <a:srgbClr val="111111"/>
                 </a:solidFill>
                 <a:latin typeface="Arial" panose="020B0604020202020204" pitchFamily="34" charset="0"/>
               </a:rPr>
-              <a:t>REPOSITORY HIGHLIGHTS</a:t>
-            </a:r>
-            <a:endParaRPr kumimoji="1" lang="ja-JP" altLang="en-US" sz="3400" b="1">
-              <a:solidFill>
-                <a:srgbClr val="111111"/>
-              </a:solidFill>
-              <a:latin typeface="Arial" panose="020B0604020202020204" pitchFamily="34" charset="0"/>
-            </a:endParaRPr>
+              <a:t>リポジトリの読みどころ</a:t>
+            </a:r>
           </a:p>
         </p:txBody>
       </p:sp>
@@ -4809,7 +4801,7 @@
           <p:cNvPr id="4" name="テキスト ボックス 3">
             <a:extLst>
               <a:ext uri="{FF2B5EF4-FFF2-40B4-BE49-F238E27FC236}">
-                <a16:creationId xmlns:a16="http://schemas.microsoft.com/office/drawing/2014/main" id="{7A27001D-1416-DE3D-3873-9883C174AEB5}"/>
+                <a16:creationId xmlns:a16="http://schemas.microsoft.com/office/drawing/2014/main" id="{BB96DD5E-0759-977C-242B-E735E813BDF6}"/>
               </a:ext>
             </a:extLst>
           </p:cNvPr>
@@ -4819,7 +4811,7 @@
         <p:spPr>
           <a:xfrm>
             <a:off x="533400" y="3429000"/>
-            <a:ext cx="10795000" cy="400110"/>
+            <a:ext cx="10795000" cy="707886"/>
           </a:xfrm>
           <a:prstGeom prst="rect">
             <a:avLst/>
@@ -4833,13 +4825,77 @@
           <a:lstStyle/>
           <a:p>
             <a:r>
+              <a:rPr kumimoji="1" lang="ja-JP" altLang="en-US" sz="2000">
+                <a:solidFill>
+                  <a:srgbClr val="333333"/>
+                </a:solidFill>
+                <a:latin typeface="Arial" panose="020B0604020202020204" pitchFamily="34" charset="0"/>
+              </a:rPr>
+              <a:t>公開コード、</a:t>
+            </a:r>
+            <a:r>
               <a:rPr kumimoji="1" lang="en-US" altLang="ja-JP" sz="2000">
                 <a:solidFill>
                   <a:srgbClr val="333333"/>
                 </a:solidFill>
                 <a:latin typeface="Arial" panose="020B0604020202020204" pitchFamily="34" charset="0"/>
               </a:rPr>
-              <a:t>Public source code, README and commit history reveal the design decisions.</a:t>
+              <a:t>README</a:t>
+            </a:r>
+            <a:r>
+              <a:rPr kumimoji="1" lang="ja-JP" altLang="en-US" sz="2000">
+                <a:solidFill>
+                  <a:srgbClr val="333333"/>
+                </a:solidFill>
+                <a:latin typeface="Arial" panose="020B0604020202020204" pitchFamily="34" charset="0"/>
+              </a:rPr>
+              <a:t>、コミット履歴から設計判断を確認できます。
+主なファイル：</a:t>
+            </a:r>
+            <a:r>
+              <a:rPr kumimoji="1" lang="en-US" altLang="ja-JP" sz="2000">
+                <a:solidFill>
+                  <a:srgbClr val="333333"/>
+                </a:solidFill>
+                <a:latin typeface="Arial" panose="020B0604020202020204" pitchFamily="34" charset="0"/>
+              </a:rPr>
+              <a:t>LICENSE</a:t>
+            </a:r>
+            <a:r>
+              <a:rPr kumimoji="1" lang="ja-JP" altLang="en-US" sz="2000">
+                <a:solidFill>
+                  <a:srgbClr val="333333"/>
+                </a:solidFill>
+                <a:latin typeface="Arial" panose="020B0604020202020204" pitchFamily="34" charset="0"/>
+              </a:rPr>
+              <a:t>、</a:t>
+            </a:r>
+            <a:r>
+              <a:rPr kumimoji="1" lang="en-US" altLang="ja-JP" sz="2000">
+                <a:solidFill>
+                  <a:srgbClr val="333333"/>
+                </a:solidFill>
+                <a:latin typeface="Arial" panose="020B0604020202020204" pitchFamily="34" charset="0"/>
+              </a:rPr>
+              <a:t>README.md</a:t>
+            </a:r>
+            <a:r>
+              <a:rPr kumimoji="1" lang="ja-JP" altLang="en-US" sz="2000">
+                <a:solidFill>
+                  <a:srgbClr val="333333"/>
+                </a:solidFill>
+                <a:latin typeface="Arial" panose="020B0604020202020204" pitchFamily="34" charset="0"/>
+              </a:rPr>
+              <a:t>、</a:t>
+            </a:r>
+            <a:r>
+              <a:rPr kumimoji="1" lang="en-US" altLang="ja-JP" sz="2000">
+                <a:solidFill>
+                  <a:srgbClr val="333333"/>
+                </a:solidFill>
+                <a:latin typeface="Arial" panose="020B0604020202020204" pitchFamily="34" charset="0"/>
+              </a:rPr>
+              <a:t>app.js</a:t>
             </a:r>
             <a:endParaRPr kumimoji="1" lang="ja-JP" altLang="en-US" sz="2000">
               <a:solidFill>
@@ -4855,7 +4911,7 @@
           <p:cNvPr id="5" name="テキスト ボックス 4">
             <a:extLst>
               <a:ext uri="{FF2B5EF4-FFF2-40B4-BE49-F238E27FC236}">
-                <a16:creationId xmlns:a16="http://schemas.microsoft.com/office/drawing/2014/main" id="{F199B39B-5BFB-44CC-03DC-566CC22D1AD4}"/>
+                <a16:creationId xmlns:a16="http://schemas.microsoft.com/office/drawing/2014/main" id="{3448087C-F3E2-BB22-CEC9-A3AF4CD4464E}"/>
               </a:ext>
             </a:extLst>
           </p:cNvPr>
@@ -4902,7 +4958,7 @@
             <a:hlinkClick r:id="" action="ppaction://media"/>
             <a:extLst>
               <a:ext uri="{FF2B5EF4-FFF2-40B4-BE49-F238E27FC236}">
-                <a16:creationId xmlns:a16="http://schemas.microsoft.com/office/drawing/2014/main" id="{01DE6348-0D18-2BD4-1717-90F6AE9F7542}"/>
+                <a16:creationId xmlns:a16="http://schemas.microsoft.com/office/drawing/2014/main" id="{C69E0742-F60A-7939-57FF-C0A26F8ECD59}"/>
               </a:ext>
             </a:extLst>
           </p:cNvPr>
@@ -4937,7 +4993,7 @@
     </p:spTree>
     <p:extLst>
       <p:ext uri="{BB962C8B-B14F-4D97-AF65-F5344CB8AC3E}">
-        <p14:creationId xmlns:p14="http://schemas.microsoft.com/office/powerpoint/2010/main" val="2108824679"/>
+        <p14:creationId xmlns:p14="http://schemas.microsoft.com/office/powerpoint/2010/main" val="3729859060"/>
       </p:ext>
     </p:extLst>
   </p:cSld>
@@ -5061,7 +5117,7 @@
           <p:cNvPr id="2" name="テキスト ボックス 1">
             <a:extLst>
               <a:ext uri="{FF2B5EF4-FFF2-40B4-BE49-F238E27FC236}">
-                <a16:creationId xmlns:a16="http://schemas.microsoft.com/office/drawing/2014/main" id="{1D1F7A63-CE88-CC2B-331E-255C86428D50}"/>
+                <a16:creationId xmlns:a16="http://schemas.microsoft.com/office/drawing/2014/main" id="{EF87D2BC-055C-76E4-5D76-FECD176FC1E3}"/>
               </a:ext>
             </a:extLst>
           </p:cNvPr>
@@ -5107,7 +5163,7 @@
           <p:cNvPr id="3" name="テキスト ボックス 2">
             <a:extLst>
               <a:ext uri="{FF2B5EF4-FFF2-40B4-BE49-F238E27FC236}">
-                <a16:creationId xmlns:a16="http://schemas.microsoft.com/office/drawing/2014/main" id="{6CF495B7-3ABC-7F70-A4DB-C78AA2DD7D28}"/>
+                <a16:creationId xmlns:a16="http://schemas.microsoft.com/office/drawing/2014/main" id="{D2195B1F-DC29-15F1-2BDE-02FE8BCE6585}"/>
               </a:ext>
             </a:extLst>
           </p:cNvPr>
@@ -5131,20 +5187,14 @@
           <a:lstStyle/>
           <a:p>
             <a:r>
-              <a:rPr kumimoji="1" lang="en-US" altLang="ja-JP" sz="3400" b="1">
+              <a:rPr kumimoji="1" lang="ja-JP" altLang="en-US" sz="3400" b="1">
                 <a:solidFill>
                   <a:srgbClr val="111111"/>
                 </a:solidFill>
                 <a:latin typeface="Arial" panose="020B0604020202020204" pitchFamily="34" charset="0"/>
               </a:rPr>
-              <a:t>ITERATIVE IMPROVEMENT</a:t>
-            </a:r>
-            <a:endParaRPr kumimoji="1" lang="ja-JP" altLang="en-US" sz="3400" b="1">
-              <a:solidFill>
-                <a:srgbClr val="111111"/>
-              </a:solidFill>
-              <a:latin typeface="Arial" panose="020B0604020202020204" pitchFamily="34" charset="0"/>
-            </a:endParaRPr>
+              <a:t>コミットから分かる改善</a:t>
+            </a:r>
           </a:p>
         </p:txBody>
       </p:sp>
@@ -5153,7 +5203,7 @@
           <p:cNvPr id="4" name="テキスト ボックス 3">
             <a:extLst>
               <a:ext uri="{FF2B5EF4-FFF2-40B4-BE49-F238E27FC236}">
-                <a16:creationId xmlns:a16="http://schemas.microsoft.com/office/drawing/2014/main" id="{580B348D-AB25-7515-0534-0DABA044836D}"/>
+                <a16:creationId xmlns:a16="http://schemas.microsoft.com/office/drawing/2014/main" id="{65D26ABB-70E9-28CB-8D9B-5158C4C6D290}"/>
               </a:ext>
             </a:extLst>
           </p:cNvPr>
@@ -5177,13 +5227,22 @@
           <a:lstStyle/>
           <a:p>
             <a:r>
+              <a:rPr kumimoji="1" lang="ja-JP" altLang="en-US" sz="2000">
+                <a:solidFill>
+                  <a:srgbClr val="333333"/>
+                </a:solidFill>
+                <a:latin typeface="Arial" panose="020B0604020202020204" pitchFamily="34" charset="0"/>
+              </a:rPr>
+              <a:t>参考動画に合わせてキャンセル入力判定を改善 </a:t>
+            </a:r>
+            <a:r>
               <a:rPr kumimoji="1" lang="en-US" altLang="ja-JP" sz="2000">
                 <a:solidFill>
                   <a:srgbClr val="333333"/>
                 </a:solidFill>
                 <a:latin typeface="Arial" panose="020B0604020202020204" pitchFamily="34" charset="0"/>
               </a:rPr>
-              <a:t>Small commits continuously improve features, quality and release readiness.</a:t>
+              <a:t>(#6)</a:t>
             </a:r>
             <a:endParaRPr kumimoji="1" lang="ja-JP" altLang="en-US" sz="2000">
               <a:solidFill>
@@ -5199,7 +5258,7 @@
           <p:cNvPr id="5" name="テキスト ボックス 4">
             <a:extLst>
               <a:ext uri="{FF2B5EF4-FFF2-40B4-BE49-F238E27FC236}">
-                <a16:creationId xmlns:a16="http://schemas.microsoft.com/office/drawing/2014/main" id="{6B8D2BC7-1ABF-EAE9-4E16-D9F6C6859C32}"/>
+                <a16:creationId xmlns:a16="http://schemas.microsoft.com/office/drawing/2014/main" id="{B3724E5A-EBCD-9B97-E60D-3CD51A007F43}"/>
               </a:ext>
             </a:extLst>
           </p:cNvPr>
@@ -5246,7 +5305,7 @@
             <a:hlinkClick r:id="" action="ppaction://media"/>
             <a:extLst>
               <a:ext uri="{FF2B5EF4-FFF2-40B4-BE49-F238E27FC236}">
-                <a16:creationId xmlns:a16="http://schemas.microsoft.com/office/drawing/2014/main" id="{4276100E-87F1-D40E-CAD4-07DE20CA37C7}"/>
+                <a16:creationId xmlns:a16="http://schemas.microsoft.com/office/drawing/2014/main" id="{4BEA887E-9F63-7EF9-00C3-CC5EB8A9C586}"/>
               </a:ext>
             </a:extLst>
           </p:cNvPr>
@@ -5281,7 +5340,7 @@
     </p:spTree>
     <p:extLst>
       <p:ext uri="{BB962C8B-B14F-4D97-AF65-F5344CB8AC3E}">
-        <p14:creationId xmlns:p14="http://schemas.microsoft.com/office/powerpoint/2010/main" val="1317551368"/>
+        <p14:creationId xmlns:p14="http://schemas.microsoft.com/office/powerpoint/2010/main" val="3497579114"/>
       </p:ext>
     </p:extLst>
   </p:cSld>
@@ -5405,7 +5464,7 @@
           <p:cNvPr id="2" name="テキスト ボックス 1">
             <a:extLst>
               <a:ext uri="{FF2B5EF4-FFF2-40B4-BE49-F238E27FC236}">
-                <a16:creationId xmlns:a16="http://schemas.microsoft.com/office/drawing/2014/main" id="{4C2B0A1C-4726-34A8-ED45-AEEA8D7EE30F}"/>
+                <a16:creationId xmlns:a16="http://schemas.microsoft.com/office/drawing/2014/main" id="{4423BA6B-3219-B68F-47E6-BA74CB3B3069}"/>
               </a:ext>
             </a:extLst>
           </p:cNvPr>
@@ -5451,7 +5510,7 @@
           <p:cNvPr id="3" name="テキスト ボックス 2">
             <a:extLst>
               <a:ext uri="{FF2B5EF4-FFF2-40B4-BE49-F238E27FC236}">
-                <a16:creationId xmlns:a16="http://schemas.microsoft.com/office/drawing/2014/main" id="{333A316E-7E03-67E8-76C7-C1DD6F55220A}"/>
+                <a16:creationId xmlns:a16="http://schemas.microsoft.com/office/drawing/2014/main" id="{92EDC92D-E434-B81D-12EF-3C41EFEBEB10}"/>
               </a:ext>
             </a:extLst>
           </p:cNvPr>
@@ -5475,20 +5534,14 @@
           <a:lstStyle/>
           <a:p>
             <a:r>
-              <a:rPr kumimoji="1" lang="en-US" altLang="ja-JP" sz="3400" b="1">
+              <a:rPr kumimoji="1" lang="ja-JP" altLang="en-US" sz="3400" b="1">
                 <a:solidFill>
                   <a:srgbClr val="111111"/>
                 </a:solidFill>
                 <a:latin typeface="Arial" panose="020B0604020202020204" pitchFamily="34" charset="0"/>
               </a:rPr>
-              <a:t>READ THE FULL ARTICLE</a:t>
-            </a:r>
-            <a:endParaRPr kumimoji="1" lang="ja-JP" altLang="en-US" sz="3400" b="1">
-              <a:solidFill>
-                <a:srgbClr val="111111"/>
-              </a:solidFill>
-              <a:latin typeface="Arial" panose="020B0604020202020204" pitchFamily="34" charset="0"/>
-            </a:endParaRPr>
+              <a:t>詳しくは積み上げログへ</a:t>
+            </a:r>
           </a:p>
         </p:txBody>
       </p:sp>
@@ -5497,7 +5550,7 @@
           <p:cNvPr id="4" name="テキスト ボックス 3">
             <a:extLst>
               <a:ext uri="{FF2B5EF4-FFF2-40B4-BE49-F238E27FC236}">
-                <a16:creationId xmlns:a16="http://schemas.microsoft.com/office/drawing/2014/main" id="{B539F5F9-B178-0177-0115-96ECC0CA41E9}"/>
+                <a16:creationId xmlns:a16="http://schemas.microsoft.com/office/drawing/2014/main" id="{8F20D795-B8B8-F7AE-ECD1-1D33D37F499B}"/>
               </a:ext>
             </a:extLst>
           </p:cNvPr>
@@ -5521,14 +5574,32 @@
           <a:lstStyle/>
           <a:p>
             <a:r>
-              <a:rPr kumimoji="1" lang="sv-SE" altLang="ja-JP" sz="2000">
+              <a:rPr kumimoji="1" lang="zh-TW" altLang="en-US" sz="2000">
+                <a:solidFill>
+                  <a:srgbClr val="333333"/>
+                </a:solidFill>
+                <a:latin typeface="Arial" panose="020B0604020202020204" pitchFamily="34" charset="0"/>
+              </a:rPr>
+              <a:t>記事： </a:t>
+            </a:r>
+            <a:r>
+              <a:rPr kumimoji="1" lang="en-US" altLang="zh-TW" sz="2000">
                 <a:solidFill>
                   <a:srgbClr val="333333"/>
                 </a:solidFill>
                 <a:latin typeface="Arial" panose="020B0604020202020204" pitchFamily="34" charset="0"/>
               </a:rPr>
               <a:t>https://syunnjack.dev/articles/akecom-spa2x-ryu
-TSUMIAGE LOG</a:t>
+</a:t>
+            </a:r>
+            <a:r>
+              <a:rPr kumimoji="1" lang="zh-TW" altLang="en-US" sz="2000">
+                <a:solidFill>
+                  <a:srgbClr val="333333"/>
+                </a:solidFill>
+                <a:latin typeface="Arial" panose="020B0604020202020204" pitchFamily="34" charset="0"/>
+              </a:rPr>
+              <a:t>学び、作り、振り返る開発記録。</a:t>
             </a:r>
             <a:endParaRPr kumimoji="1" lang="ja-JP" altLang="en-US" sz="2000">
               <a:solidFill>
@@ -5544,7 +5615,7 @@
           <p:cNvPr id="5" name="テキスト ボックス 4">
             <a:extLst>
               <a:ext uri="{FF2B5EF4-FFF2-40B4-BE49-F238E27FC236}">
-                <a16:creationId xmlns:a16="http://schemas.microsoft.com/office/drawing/2014/main" id="{3E811F5F-4823-2400-E456-5DFDA4F60FCA}"/>
+                <a16:creationId xmlns:a16="http://schemas.microsoft.com/office/drawing/2014/main" id="{84DA5960-D7B4-852E-AFCB-8B5BD89684E6}"/>
               </a:ext>
             </a:extLst>
           </p:cNvPr>
@@ -5591,7 +5662,7 @@
             <a:hlinkClick r:id="" action="ppaction://media"/>
             <a:extLst>
               <a:ext uri="{FF2B5EF4-FFF2-40B4-BE49-F238E27FC236}">
-                <a16:creationId xmlns:a16="http://schemas.microsoft.com/office/drawing/2014/main" id="{156EC082-7D47-B321-ADBE-DBA8FBD15C42}"/>
+                <a16:creationId xmlns:a16="http://schemas.microsoft.com/office/drawing/2014/main" id="{D73A9D01-DFDE-96FB-F360-1C2AAECB71B8}"/>
               </a:ext>
             </a:extLst>
           </p:cNvPr>
@@ -5626,7 +5697,7 @@
     </p:spTree>
     <p:extLst>
       <p:ext uri="{BB962C8B-B14F-4D97-AF65-F5344CB8AC3E}">
-        <p14:creationId xmlns:p14="http://schemas.microsoft.com/office/powerpoint/2010/main" val="1997242610"/>
+        <p14:creationId xmlns:p14="http://schemas.microsoft.com/office/powerpoint/2010/main" val="1445193656"/>
       </p:ext>
     </p:extLst>
   </p:cSld>

</xml_diff>